<commit_message>
some improvements on slides ltlb and ctl
</commit_message>
<xml_diff>
--- a/slides/PV_ltlb.pptx
+++ b/slides/PV_ltlb.pptx
@@ -13464,21 +13464,23 @@
         <p:nvCxnSpPr>
           <p:cNvPr id="17" name="Rechte verbindingslijn met pijl 16"/>
           <p:cNvCxnSpPr>
-            <a:stCxn id="8" idx="1"/>
-            <a:endCxn id="5" idx="5"/>
+            <a:cxnSpLocks/>
+            <a:stCxn id="7" idx="0"/>
+            <a:endCxn id="5" idx="4"/>
           </p:cNvCxnSpPr>
           <p:nvPr/>
         </p:nvCxnSpPr>
         <p:spPr bwMode="auto">
-          <a:xfrm rot="16200000" flipV="1">
-            <a:off x="972343" y="1707357"/>
-            <a:ext cx="830263" cy="812800"/>
+          <a:xfrm flipH="1" flipV="1">
+            <a:off x="905593" y="1730354"/>
+            <a:ext cx="59608" cy="746146"/>
           </a:xfrm>
           <a:prstGeom prst="straightConnector1">
             <a:avLst/>
           </a:prstGeom>
           <a:ln>
-            <a:tailEnd type="arrow"/>
+            <a:headEnd type="none" w="med" len="med"/>
+            <a:tailEnd type="arrow" w="med" len="med"/>
           </a:ln>
         </p:spPr>
         <p:style>
@@ -14077,21 +14079,23 @@
         <p:nvCxnSpPr>
           <p:cNvPr id="62" name="Rechte verbindingslijn met pijl 61"/>
           <p:cNvCxnSpPr>
-            <a:stCxn id="58" idx="1"/>
-            <a:endCxn id="55" idx="5"/>
+            <a:cxnSpLocks/>
+            <a:stCxn id="57" idx="0"/>
+            <a:endCxn id="55" idx="4"/>
           </p:cNvCxnSpPr>
           <p:nvPr/>
         </p:nvCxnSpPr>
         <p:spPr>
-          <a:xfrm rot="16200000" flipV="1">
-            <a:off x="3772693" y="4355307"/>
-            <a:ext cx="830263" cy="812800"/>
+          <a:xfrm flipH="1" flipV="1">
+            <a:off x="3706477" y="4377582"/>
+            <a:ext cx="59074" cy="745281"/>
           </a:xfrm>
           <a:prstGeom prst="straightConnector1">
             <a:avLst/>
           </a:prstGeom>
           <a:ln>
-            <a:tailEnd type="arrow"/>
+            <a:headEnd type="none" w="med" len="med"/>
+            <a:tailEnd type="arrow" w="med" len="med"/>
           </a:ln>
         </p:spPr>
         <p:style>
@@ -14514,48 +14518,6 @@
             <a:avLst/>
           </a:prstGeom>
           <a:ln>
-            <a:tailEnd type="arrow"/>
-          </a:ln>
-        </p:spPr>
-        <p:style>
-          <a:lnRef idx="2">
-            <a:schemeClr val="dk1"/>
-          </a:lnRef>
-          <a:fillRef idx="0">
-            <a:schemeClr val="dk1"/>
-          </a:fillRef>
-          <a:effectRef idx="1">
-            <a:schemeClr val="dk1"/>
-          </a:effectRef>
-          <a:fontRef idx="minor">
-            <a:schemeClr val="tx1"/>
-          </a:fontRef>
-        </p:style>
-      </p:cxnSp>
-      <p:cxnSp>
-        <p:nvCxnSpPr>
-          <p:cNvPr id="77" name="Rechte verbindingslijn met pijl 76"/>
-          <p:cNvCxnSpPr>
-            <a:stCxn id="73" idx="1"/>
-            <a:endCxn id="70" idx="5"/>
-          </p:cNvCxnSpPr>
-          <p:nvPr/>
-        </p:nvCxnSpPr>
-        <p:spPr>
-          <a:xfrm rot="16200000" flipV="1">
-            <a:off x="7381875" y="4387851"/>
-            <a:ext cx="828675" cy="812800"/>
-          </a:xfrm>
-          <a:prstGeom prst="straightConnector1">
-            <a:avLst/>
-          </a:prstGeom>
-          <a:ln>
-            <a:solidFill>
-              <a:schemeClr val="accent2">
-                <a:lumMod val="75000"/>
-              </a:schemeClr>
-            </a:solidFill>
-            <a:prstDash val="dash"/>
             <a:tailEnd type="arrow"/>
           </a:ln>
         </p:spPr>
@@ -15002,101 +14964,6 @@
       </p:sp>
       <p:sp>
         <p:nvSpPr>
-          <p:cNvPr id="91" name="Vrije vorm 90"/>
-          <p:cNvSpPr/>
-          <p:nvPr/>
-        </p:nvSpPr>
-        <p:spPr>
-          <a:xfrm>
-            <a:off x="3970338" y="4405313"/>
-            <a:ext cx="4294187" cy="1885950"/>
-          </a:xfrm>
-          <a:custGeom>
-            <a:avLst/>
-            <a:gdLst>
-              <a:gd name="connsiteX0" fmla="*/ 4294415 w 4294415"/>
-              <a:gd name="connsiteY0" fmla="*/ 1110343 h 1885950"/>
-              <a:gd name="connsiteX1" fmla="*/ 3020786 w 4294415"/>
-              <a:gd name="connsiteY1" fmla="*/ 1796143 h 1885950"/>
-              <a:gd name="connsiteX2" fmla="*/ 1028700 w 4294415"/>
-              <a:gd name="connsiteY2" fmla="*/ 571500 h 1885950"/>
-              <a:gd name="connsiteX3" fmla="*/ 0 w 4294415"/>
-              <a:gd name="connsiteY3" fmla="*/ 0 h 1885950"/>
-            </a:gdLst>
-            <a:ahLst/>
-            <a:cxnLst>
-              <a:cxn ang="0">
-                <a:pos x="connsiteX0" y="connsiteY0"/>
-              </a:cxn>
-              <a:cxn ang="0">
-                <a:pos x="connsiteX1" y="connsiteY1"/>
-              </a:cxn>
-              <a:cxn ang="0">
-                <a:pos x="connsiteX2" y="connsiteY2"/>
-              </a:cxn>
-              <a:cxn ang="0">
-                <a:pos x="connsiteX3" y="connsiteY3"/>
-              </a:cxn>
-            </a:cxnLst>
-            <a:rect l="l" t="t" r="r" b="b"/>
-            <a:pathLst>
-              <a:path w="4294415" h="1885950">
-                <a:moveTo>
-                  <a:pt x="4294415" y="1110343"/>
-                </a:moveTo>
-                <a:cubicBezTo>
-                  <a:pt x="3929743" y="1498146"/>
-                  <a:pt x="3565072" y="1885950"/>
-                  <a:pt x="3020786" y="1796143"/>
-                </a:cubicBezTo>
-                <a:cubicBezTo>
-                  <a:pt x="2476500" y="1706336"/>
-                  <a:pt x="1532164" y="870857"/>
-                  <a:pt x="1028700" y="571500"/>
-                </a:cubicBezTo>
-                <a:cubicBezTo>
-                  <a:pt x="525236" y="272143"/>
-                  <a:pt x="262618" y="136071"/>
-                  <a:pt x="0" y="0"/>
-                </a:cubicBezTo>
-              </a:path>
-            </a:pathLst>
-          </a:custGeom>
-          <a:ln>
-            <a:solidFill>
-              <a:schemeClr val="accent1"/>
-            </a:solidFill>
-            <a:headEnd type="none" w="med" len="med"/>
-            <a:tailEnd type="triangle" w="med" len="med"/>
-          </a:ln>
-        </p:spPr>
-        <p:style>
-          <a:lnRef idx="3">
-            <a:schemeClr val="accent2"/>
-          </a:lnRef>
-          <a:fillRef idx="0">
-            <a:schemeClr val="accent2"/>
-          </a:fillRef>
-          <a:effectRef idx="2">
-            <a:schemeClr val="accent2"/>
-          </a:effectRef>
-          <a:fontRef idx="minor">
-            <a:schemeClr val="tx1"/>
-          </a:fontRef>
-        </p:style>
-        <p:txBody>
-          <a:bodyPr anchor="ctr"/>
-          <a:lstStyle/>
-          <a:p>
-            <a:pPr algn="ctr">
-              <a:defRPr/>
-            </a:pPr>
-            <a:endParaRPr lang="en-US"/>
-          </a:p>
-        </p:txBody>
-      </p:sp>
-      <p:sp>
-        <p:nvSpPr>
           <p:cNvPr id="94" name="Ovaal 93"/>
           <p:cNvSpPr/>
           <p:nvPr/>
@@ -15156,8 +15023,8 @@
         </p:nvSpPr>
         <p:spPr bwMode="auto">
           <a:xfrm>
-            <a:off x="1700213" y="3197225"/>
-            <a:ext cx="1600200" cy="738188"/>
+            <a:off x="1117616" y="3237240"/>
+            <a:ext cx="2057384" cy="523220"/>
           </a:xfrm>
           <a:prstGeom prst="rect">
             <a:avLst/>
@@ -15171,16 +15038,45 @@
           </a:ln>
         </p:spPr>
         <p:txBody>
-          <a:bodyPr>
+          <a:bodyPr wrap="square">
             <a:spAutoFit/>
           </a:bodyPr>
           <a:lstStyle/>
           <a:p>
-            <a:r>
-              <a:rPr lang="nl-NL" sz="1400"/>
-              <a:t>single accentance group of the new automaton</a:t>
-            </a:r>
-            <a:endParaRPr lang="en-US" sz="1400"/>
+            <a:pPr algn="r"/>
+            <a:r>
+              <a:rPr lang="nl-NL" sz="1400" dirty="0"/>
+              <a:t>single </a:t>
+            </a:r>
+            <a:r>
+              <a:rPr lang="nl-NL" sz="1400" dirty="0" err="1"/>
+              <a:t>accentance</a:t>
+            </a:r>
+            <a:r>
+              <a:rPr lang="nl-NL" sz="1400" dirty="0"/>
+              <a:t> </a:t>
+            </a:r>
+            <a:r>
+              <a:rPr lang="nl-NL" sz="1400" dirty="0" err="1"/>
+              <a:t>group</a:t>
+            </a:r>
+            <a:r>
+              <a:rPr lang="nl-NL" sz="1400" dirty="0"/>
+              <a:t> of </a:t>
+            </a:r>
+            <a:r>
+              <a:rPr lang="nl-NL" sz="1400" dirty="0" err="1"/>
+              <a:t>the</a:t>
+            </a:r>
+            <a:r>
+              <a:rPr lang="nl-NL" sz="1400" dirty="0"/>
+              <a:t> new </a:t>
+            </a:r>
+            <a:r>
+              <a:rPr lang="nl-NL" sz="1400" dirty="0" err="1"/>
+              <a:t>automaton</a:t>
+            </a:r>
+            <a:endParaRPr lang="en-US" sz="1400" dirty="0"/>
           </a:p>
         </p:txBody>
       </p:sp>
@@ -15200,7 +15096,7 @@
           <a:prstGeom prst="line">
             <a:avLst/>
           </a:prstGeom>
-          <a:ln>
+          <a:ln w="28575">
             <a:solidFill>
               <a:schemeClr val="bg1">
                 <a:lumMod val="65000"/>
@@ -15255,7 +15151,7 @@
           <a:p>
             <a:pPr algn="r"/>
             <a:r>
-              <a:rPr lang="en-US" sz="1600"/>
+              <a:rPr lang="en-US" sz="1600" dirty="0"/>
               <a:t>dashed-red arrows are dropped</a:t>
             </a:r>
           </a:p>
@@ -15328,7 +15224,7 @@
           <a:prstGeom prst="line">
             <a:avLst/>
           </a:prstGeom>
-          <a:ln>
+          <a:ln w="28575">
             <a:solidFill>
               <a:schemeClr val="bg1">
                 <a:lumMod val="65000"/>
@@ -15345,6 +15241,464 @@
           </a:fillRef>
           <a:effectRef idx="0">
             <a:schemeClr val="accent1"/>
+          </a:effectRef>
+          <a:fontRef idx="minor">
+            <a:schemeClr val="tx1"/>
+          </a:fontRef>
+        </p:style>
+      </p:cxnSp>
+      <p:cxnSp>
+        <p:nvCxnSpPr>
+          <p:cNvPr id="3" name="Vorm 11">
+            <a:extLst>
+              <a:ext uri="{FF2B5EF4-FFF2-40B4-BE49-F238E27FC236}">
+                <a16:creationId xmlns:a16="http://schemas.microsoft.com/office/drawing/2014/main" id="{BBBBA6AE-FF87-9D52-4124-8C0A7E4EACB7}"/>
+              </a:ext>
+            </a:extLst>
+          </p:cNvPr>
+          <p:cNvCxnSpPr>
+            <a:cxnSpLocks/>
+            <a:stCxn id="6" idx="5"/>
+            <a:endCxn id="6" idx="7"/>
+          </p:cNvCxnSpPr>
+          <p:nvPr/>
+        </p:nvCxnSpPr>
+        <p:spPr bwMode="auto">
+          <a:xfrm rot="5400000" flipH="1">
+            <a:off x="1907206" y="1645954"/>
+            <a:ext cx="150160" cy="12700"/>
+          </a:xfrm>
+          <a:prstGeom prst="curvedConnector5">
+            <a:avLst>
+              <a:gd name="adj1" fmla="val -152238"/>
+              <a:gd name="adj2" fmla="val -3026496"/>
+              <a:gd name="adj3" fmla="val 252238"/>
+            </a:avLst>
+          </a:prstGeom>
+          <a:ln>
+            <a:tailEnd type="arrow"/>
+          </a:ln>
+        </p:spPr>
+        <p:style>
+          <a:lnRef idx="2">
+            <a:schemeClr val="dk1"/>
+          </a:lnRef>
+          <a:fillRef idx="0">
+            <a:schemeClr val="dk1"/>
+          </a:fillRef>
+          <a:effectRef idx="1">
+            <a:schemeClr val="dk1"/>
+          </a:effectRef>
+          <a:fontRef idx="minor">
+            <a:schemeClr val="tx1"/>
+          </a:fontRef>
+        </p:style>
+      </p:cxnSp>
+      <p:sp>
+        <p:nvSpPr>
+          <p:cNvPr id="15" name="Vrije vorm 87">
+            <a:extLst>
+              <a:ext uri="{FF2B5EF4-FFF2-40B4-BE49-F238E27FC236}">
+                <a16:creationId xmlns:a16="http://schemas.microsoft.com/office/drawing/2014/main" id="{9A7064C9-30A0-60DB-31AD-7B45D30CA798}"/>
+              </a:ext>
+            </a:extLst>
+          </p:cNvPr>
+          <p:cNvSpPr/>
+          <p:nvPr/>
+        </p:nvSpPr>
+        <p:spPr>
+          <a:xfrm>
+            <a:off x="4716461" y="3373438"/>
+            <a:ext cx="3455989" cy="850900"/>
+          </a:xfrm>
+          <a:custGeom>
+            <a:avLst/>
+            <a:gdLst>
+              <a:gd name="connsiteX0" fmla="*/ 0 w 4327071"/>
+              <a:gd name="connsiteY0" fmla="*/ 971550 h 971550"/>
+              <a:gd name="connsiteX1" fmla="*/ 3020785 w 4327071"/>
+              <a:gd name="connsiteY1" fmla="*/ 8164 h 971550"/>
+              <a:gd name="connsiteX2" fmla="*/ 4327071 w 4327071"/>
+              <a:gd name="connsiteY2" fmla="*/ 922564 h 971550"/>
+            </a:gdLst>
+            <a:ahLst/>
+            <a:cxnLst>
+              <a:cxn ang="0">
+                <a:pos x="connsiteX0" y="connsiteY0"/>
+              </a:cxn>
+              <a:cxn ang="0">
+                <a:pos x="connsiteX1" y="connsiteY1"/>
+              </a:cxn>
+              <a:cxn ang="0">
+                <a:pos x="connsiteX2" y="connsiteY2"/>
+              </a:cxn>
+            </a:cxnLst>
+            <a:rect l="l" t="t" r="r" b="b"/>
+            <a:pathLst>
+              <a:path w="4327071" h="971550">
+                <a:moveTo>
+                  <a:pt x="0" y="971550"/>
+                </a:moveTo>
+                <a:cubicBezTo>
+                  <a:pt x="1149803" y="493939"/>
+                  <a:pt x="2299607" y="16328"/>
+                  <a:pt x="3020785" y="8164"/>
+                </a:cubicBezTo>
+                <a:cubicBezTo>
+                  <a:pt x="3741963" y="0"/>
+                  <a:pt x="4034517" y="461282"/>
+                  <a:pt x="4327071" y="922564"/>
+                </a:cubicBezTo>
+              </a:path>
+            </a:pathLst>
+          </a:custGeom>
+          <a:ln>
+            <a:headEnd type="none" w="med" len="med"/>
+            <a:tailEnd type="triangle" w="med" len="med"/>
+          </a:ln>
+        </p:spPr>
+        <p:style>
+          <a:lnRef idx="3">
+            <a:schemeClr val="accent4"/>
+          </a:lnRef>
+          <a:fillRef idx="0">
+            <a:schemeClr val="accent4"/>
+          </a:fillRef>
+          <a:effectRef idx="2">
+            <a:schemeClr val="accent4"/>
+          </a:effectRef>
+          <a:fontRef idx="minor">
+            <a:schemeClr val="tx1"/>
+          </a:fontRef>
+        </p:style>
+        <p:txBody>
+          <a:bodyPr anchor="ctr"/>
+          <a:lstStyle/>
+          <a:p>
+            <a:pPr algn="ctr">
+              <a:defRPr/>
+            </a:pPr>
+            <a:endParaRPr lang="en-US"/>
+          </a:p>
+        </p:txBody>
+      </p:sp>
+      <p:cxnSp>
+        <p:nvCxnSpPr>
+          <p:cNvPr id="16" name="Vorm 59">
+            <a:extLst>
+              <a:ext uri="{FF2B5EF4-FFF2-40B4-BE49-F238E27FC236}">
+                <a16:creationId xmlns:a16="http://schemas.microsoft.com/office/drawing/2014/main" id="{E4FDE51C-5A91-BD2A-AC24-E35F77BABC7D}"/>
+              </a:ext>
+            </a:extLst>
+          </p:cNvPr>
+          <p:cNvCxnSpPr>
+            <a:cxnSpLocks/>
+            <a:stCxn id="56" idx="5"/>
+            <a:endCxn id="56" idx="0"/>
+          </p:cNvCxnSpPr>
+          <p:nvPr/>
+        </p:nvCxnSpPr>
+        <p:spPr>
+          <a:xfrm rot="5400000" flipH="1">
+            <a:off x="4654894" y="4240150"/>
+            <a:ext cx="181185" cy="75049"/>
+          </a:xfrm>
+          <a:prstGeom prst="curvedConnector5">
+            <a:avLst>
+              <a:gd name="adj1" fmla="val -126169"/>
+              <a:gd name="adj2" fmla="val -449889"/>
+              <a:gd name="adj3" fmla="val 226169"/>
+            </a:avLst>
+          </a:prstGeom>
+          <a:ln>
+            <a:solidFill>
+              <a:schemeClr val="accent2">
+                <a:lumMod val="75000"/>
+              </a:schemeClr>
+            </a:solidFill>
+            <a:prstDash val="dash"/>
+            <a:tailEnd type="arrow"/>
+          </a:ln>
+        </p:spPr>
+        <p:style>
+          <a:lnRef idx="2">
+            <a:schemeClr val="dk1"/>
+          </a:lnRef>
+          <a:fillRef idx="0">
+            <a:schemeClr val="dk1"/>
+          </a:fillRef>
+          <a:effectRef idx="1">
+            <a:schemeClr val="dk1"/>
+          </a:effectRef>
+          <a:fontRef idx="minor">
+            <a:schemeClr val="tx1"/>
+          </a:fontRef>
+        </p:style>
+      </p:cxnSp>
+      <p:cxnSp>
+        <p:nvCxnSpPr>
+          <p:cNvPr id="25" name="Vorm 74">
+            <a:extLst>
+              <a:ext uri="{FF2B5EF4-FFF2-40B4-BE49-F238E27FC236}">
+                <a16:creationId xmlns:a16="http://schemas.microsoft.com/office/drawing/2014/main" id="{0247074C-60A2-91BA-9344-B2E8DF1FE88D}"/>
+              </a:ext>
+            </a:extLst>
+          </p:cNvPr>
+          <p:cNvCxnSpPr>
+            <a:cxnSpLocks/>
+            <a:stCxn id="71" idx="4"/>
+            <a:endCxn id="71" idx="0"/>
+          </p:cNvCxnSpPr>
+          <p:nvPr/>
+        </p:nvCxnSpPr>
+        <p:spPr>
+          <a:xfrm rot="5400000" flipH="1">
+            <a:off x="8210440" y="4325873"/>
+            <a:ext cx="212272" cy="12700"/>
+          </a:xfrm>
+          <a:prstGeom prst="curvedConnector5">
+            <a:avLst>
+              <a:gd name="adj1" fmla="val -107692"/>
+              <a:gd name="adj2" fmla="val -3437331"/>
+              <a:gd name="adj3" fmla="val 207692"/>
+            </a:avLst>
+          </a:prstGeom>
+          <a:ln>
+            <a:tailEnd type="arrow"/>
+          </a:ln>
+        </p:spPr>
+        <p:style>
+          <a:lnRef idx="2">
+            <a:schemeClr val="dk1"/>
+          </a:lnRef>
+          <a:fillRef idx="0">
+            <a:schemeClr val="dk1"/>
+          </a:fillRef>
+          <a:effectRef idx="1">
+            <a:schemeClr val="dk1"/>
+          </a:effectRef>
+          <a:fontRef idx="minor">
+            <a:schemeClr val="tx1"/>
+          </a:fontRef>
+        </p:style>
+      </p:cxnSp>
+      <p:cxnSp>
+        <p:nvCxnSpPr>
+          <p:cNvPr id="41" name="Rechte verbindingslijn met pijl 61">
+            <a:extLst>
+              <a:ext uri="{FF2B5EF4-FFF2-40B4-BE49-F238E27FC236}">
+                <a16:creationId xmlns:a16="http://schemas.microsoft.com/office/drawing/2014/main" id="{9531B77B-3E4D-F1C3-B06A-48580450ED6F}"/>
+              </a:ext>
+            </a:extLst>
+          </p:cNvPr>
+          <p:cNvCxnSpPr>
+            <a:cxnSpLocks/>
+            <a:stCxn id="72" idx="0"/>
+            <a:endCxn id="70" idx="4"/>
+          </p:cNvCxnSpPr>
+          <p:nvPr/>
+        </p:nvCxnSpPr>
+        <p:spPr>
+          <a:xfrm flipH="1" flipV="1">
+            <a:off x="7315091" y="4410238"/>
+            <a:ext cx="58847" cy="745962"/>
+          </a:xfrm>
+          <a:prstGeom prst="straightConnector1">
+            <a:avLst/>
+          </a:prstGeom>
+          <a:ln>
+            <a:headEnd type="none" w="med" len="med"/>
+            <a:tailEnd type="arrow" w="med" len="med"/>
+          </a:ln>
+        </p:spPr>
+        <p:style>
+          <a:lnRef idx="2">
+            <a:schemeClr val="dk1"/>
+          </a:lnRef>
+          <a:fillRef idx="0">
+            <a:schemeClr val="dk1"/>
+          </a:fillRef>
+          <a:effectRef idx="1">
+            <a:schemeClr val="dk1"/>
+          </a:effectRef>
+          <a:fontRef idx="minor">
+            <a:schemeClr val="tx1"/>
+          </a:fontRef>
+        </p:style>
+      </p:cxnSp>
+      <p:cxnSp>
+        <p:nvCxnSpPr>
+          <p:cNvPr id="46" name="Rechte verbindingslijn met pijl 16">
+            <a:extLst>
+              <a:ext uri="{FF2B5EF4-FFF2-40B4-BE49-F238E27FC236}">
+                <a16:creationId xmlns:a16="http://schemas.microsoft.com/office/drawing/2014/main" id="{8420125B-A002-9456-7E74-3B939BD27D47}"/>
+              </a:ext>
+            </a:extLst>
+          </p:cNvPr>
+          <p:cNvCxnSpPr>
+            <a:cxnSpLocks/>
+            <a:stCxn id="5" idx="5"/>
+            <a:endCxn id="7" idx="7"/>
+          </p:cNvCxnSpPr>
+          <p:nvPr/>
+        </p:nvCxnSpPr>
+        <p:spPr bwMode="auto">
+          <a:xfrm>
+            <a:off x="980653" y="1699255"/>
+            <a:ext cx="59757" cy="808398"/>
+          </a:xfrm>
+          <a:prstGeom prst="straightConnector1">
+            <a:avLst/>
+          </a:prstGeom>
+          <a:ln>
+            <a:headEnd type="none" w="med" len="med"/>
+            <a:tailEnd type="arrow" w="med" len="med"/>
+          </a:ln>
+        </p:spPr>
+        <p:style>
+          <a:lnRef idx="2">
+            <a:schemeClr val="dk1"/>
+          </a:lnRef>
+          <a:fillRef idx="0">
+            <a:schemeClr val="dk1"/>
+          </a:fillRef>
+          <a:effectRef idx="1">
+            <a:schemeClr val="dk1"/>
+          </a:effectRef>
+          <a:fontRef idx="minor">
+            <a:schemeClr val="tx1"/>
+          </a:fontRef>
+        </p:style>
+      </p:cxnSp>
+      <p:cxnSp>
+        <p:nvCxnSpPr>
+          <p:cNvPr id="51" name="Rechte verbindingslijn met pijl 61">
+            <a:extLst>
+              <a:ext uri="{FF2B5EF4-FFF2-40B4-BE49-F238E27FC236}">
+                <a16:creationId xmlns:a16="http://schemas.microsoft.com/office/drawing/2014/main" id="{0949C14A-B416-3A6B-A1F3-106292699D80}"/>
+              </a:ext>
+            </a:extLst>
+          </p:cNvPr>
+          <p:cNvCxnSpPr>
+            <a:cxnSpLocks/>
+            <a:stCxn id="55" idx="5"/>
+            <a:endCxn id="57" idx="7"/>
+          </p:cNvCxnSpPr>
+          <p:nvPr/>
+        </p:nvCxnSpPr>
+        <p:spPr>
+          <a:xfrm>
+            <a:off x="3781526" y="4346495"/>
+            <a:ext cx="59234" cy="807521"/>
+          </a:xfrm>
+          <a:prstGeom prst="straightConnector1">
+            <a:avLst/>
+          </a:prstGeom>
+          <a:ln>
+            <a:solidFill>
+              <a:srgbClr val="C00000"/>
+            </a:solidFill>
+            <a:prstDash val="dash"/>
+            <a:headEnd type="none" w="med" len="med"/>
+            <a:tailEnd type="arrow" w="med" len="med"/>
+          </a:ln>
+        </p:spPr>
+        <p:style>
+          <a:lnRef idx="2">
+            <a:schemeClr val="dk1"/>
+          </a:lnRef>
+          <a:fillRef idx="0">
+            <a:schemeClr val="dk1"/>
+          </a:fillRef>
+          <a:effectRef idx="1">
+            <a:schemeClr val="dk1"/>
+          </a:effectRef>
+          <a:fontRef idx="minor">
+            <a:schemeClr val="tx1"/>
+          </a:fontRef>
+        </p:style>
+      </p:cxnSp>
+      <p:cxnSp>
+        <p:nvCxnSpPr>
+          <p:cNvPr id="21507" name="Rechte verbindingslijn met pijl 84">
+            <a:extLst>
+              <a:ext uri="{FF2B5EF4-FFF2-40B4-BE49-F238E27FC236}">
+                <a16:creationId xmlns:a16="http://schemas.microsoft.com/office/drawing/2014/main" id="{95D61087-5767-074F-052E-DD0643072DAB}"/>
+              </a:ext>
+            </a:extLst>
+          </p:cNvPr>
+          <p:cNvCxnSpPr>
+            <a:cxnSpLocks/>
+            <a:stCxn id="55" idx="5"/>
+            <a:endCxn id="72" idx="2"/>
+          </p:cNvCxnSpPr>
+          <p:nvPr/>
+        </p:nvCxnSpPr>
+        <p:spPr>
+          <a:xfrm>
+            <a:off x="3781526" y="4346495"/>
+            <a:ext cx="3486049" cy="916068"/>
+          </a:xfrm>
+          <a:prstGeom prst="straightConnector1">
+            <a:avLst/>
+          </a:prstGeom>
+          <a:ln>
+            <a:tailEnd type="arrow"/>
+          </a:ln>
+        </p:spPr>
+        <p:style>
+          <a:lnRef idx="3">
+            <a:schemeClr val="accent4"/>
+          </a:lnRef>
+          <a:fillRef idx="0">
+            <a:schemeClr val="accent4"/>
+          </a:fillRef>
+          <a:effectRef idx="2">
+            <a:schemeClr val="accent4"/>
+          </a:effectRef>
+          <a:fontRef idx="minor">
+            <a:schemeClr val="tx1"/>
+          </a:fontRef>
+        </p:style>
+      </p:cxnSp>
+      <p:cxnSp>
+        <p:nvCxnSpPr>
+          <p:cNvPr id="21511" name="Rechte verbindingslijn met pijl 61">
+            <a:extLst>
+              <a:ext uri="{FF2B5EF4-FFF2-40B4-BE49-F238E27FC236}">
+                <a16:creationId xmlns:a16="http://schemas.microsoft.com/office/drawing/2014/main" id="{85EACC4E-24F3-6B5B-9942-3B46AF3A81BC}"/>
+              </a:ext>
+            </a:extLst>
+          </p:cNvPr>
+          <p:cNvCxnSpPr>
+            <a:cxnSpLocks/>
+            <a:stCxn id="70" idx="5"/>
+            <a:endCxn id="72" idx="7"/>
+          </p:cNvCxnSpPr>
+          <p:nvPr/>
+        </p:nvCxnSpPr>
+        <p:spPr>
+          <a:xfrm>
+            <a:off x="7390140" y="4379151"/>
+            <a:ext cx="59007" cy="808202"/>
+          </a:xfrm>
+          <a:prstGeom prst="straightConnector1">
+            <a:avLst/>
+          </a:prstGeom>
+          <a:ln>
+            <a:headEnd type="none" w="med" len="med"/>
+            <a:tailEnd type="arrow" w="med" len="med"/>
+          </a:ln>
+        </p:spPr>
+        <p:style>
+          <a:lnRef idx="2">
+            <a:schemeClr val="dk1"/>
+          </a:lnRef>
+          <a:fillRef idx="0">
+            <a:schemeClr val="dk1"/>
+          </a:fillRef>
+          <a:effectRef idx="1">
+            <a:schemeClr val="dk1"/>
           </a:effectRef>
           <a:fontRef idx="minor">
             <a:schemeClr val="tx1"/>
@@ -15377,7 +15731,7 @@
                             </p:stCondLst>
                             <p:childTnLst>
                               <p:par>
-                                <p:cTn id="5" presetID="1" presetClass="entr" presetSubtype="0" fill="hold" nodeType="clickEffect">
+                                <p:cTn id="5" presetID="1" presetClass="entr" presetSubtype="0" fill="hold" grpId="0" nodeType="clickEffect">
                                   <p:stCondLst>
                                     <p:cond delay="0"/>
                                   </p:stCondLst>
@@ -15385,6 +15739,87 @@
                                     <p:set>
                                       <p:cBhvr>
                                         <p:cTn id="6" dur="1" fill="hold">
+                                          <p:stCondLst>
+                                            <p:cond delay="0"/>
+                                          </p:stCondLst>
+                                        </p:cTn>
+                                        <p:tgtEl>
+                                          <p:spTgt spid="15"/>
+                                        </p:tgtEl>
+                                        <p:attrNameLst>
+                                          <p:attrName>style.visibility</p:attrName>
+                                        </p:attrNameLst>
+                                      </p:cBhvr>
+                                      <p:to>
+                                        <p:strVal val="visible"/>
+                                      </p:to>
+                                    </p:set>
+                                  </p:childTnLst>
+                                </p:cTn>
+                              </p:par>
+                              <p:par>
+                                <p:cTn id="7" presetID="1" presetClass="entr" presetSubtype="0" fill="hold" grpId="0" nodeType="withEffect">
+                                  <p:stCondLst>
+                                    <p:cond delay="0"/>
+                                  </p:stCondLst>
+                                  <p:childTnLst>
+                                    <p:set>
+                                      <p:cBhvr>
+                                        <p:cTn id="8" dur="1" fill="hold">
+                                          <p:stCondLst>
+                                            <p:cond delay="0"/>
+                                          </p:stCondLst>
+                                        </p:cTn>
+                                        <p:tgtEl>
+                                          <p:spTgt spid="88"/>
+                                        </p:tgtEl>
+                                        <p:attrNameLst>
+                                          <p:attrName>style.visibility</p:attrName>
+                                        </p:attrNameLst>
+                                      </p:cBhvr>
+                                      <p:to>
+                                        <p:strVal val="visible"/>
+                                      </p:to>
+                                    </p:set>
+                                  </p:childTnLst>
+                                </p:cTn>
+                              </p:par>
+                              <p:par>
+                                <p:cTn id="9" presetID="1" presetClass="entr" presetSubtype="0" fill="hold" grpId="0" nodeType="withEffect">
+                                  <p:stCondLst>
+                                    <p:cond delay="0"/>
+                                  </p:stCondLst>
+                                  <p:childTnLst>
+                                    <p:set>
+                                      <p:cBhvr>
+                                        <p:cTn id="10" dur="1" fill="hold">
+                                          <p:stCondLst>
+                                            <p:cond delay="0"/>
+                                          </p:stCondLst>
+                                        </p:cTn>
+                                        <p:tgtEl>
+                                          <p:spTgt spid="87"/>
+                                        </p:tgtEl>
+                                        <p:attrNameLst>
+                                          <p:attrName>style.visibility</p:attrName>
+                                        </p:attrNameLst>
+                                      </p:cBhvr>
+                                      <p:to>
+                                        <p:strVal val="visible"/>
+                                      </p:to>
+                                    </p:set>
+                                  </p:childTnLst>
+                                </p:cTn>
+                              </p:par>
+                              <p:par>
+                                <p:cTn id="11" presetID="1" presetClass="entr" presetSubtype="0" fill="hold" nodeType="withEffect">
+                                  <p:stCondLst>
+                                    <p:cond delay="0"/>
+                                  </p:stCondLst>
+                                  <p:childTnLst>
+                                    <p:set>
+                                      <p:cBhvr>
+                                        <p:cTn id="12" dur="1" fill="hold">
                                           <p:stCondLst>
                                             <p:cond delay="0"/>
                                           </p:stCondLst>
@@ -15404,47 +15839,20 @@
                                 </p:cTn>
                               </p:par>
                               <p:par>
-                                <p:cTn id="7" presetID="1" presetClass="entr" presetSubtype="0" fill="hold" nodeType="withEffect">
+                                <p:cTn id="13" presetID="1" presetClass="entr" presetSubtype="0" fill="hold" nodeType="withEffect">
                                   <p:stCondLst>
                                     <p:cond delay="0"/>
                                   </p:stCondLst>
                                   <p:childTnLst>
                                     <p:set>
                                       <p:cBhvr>
-                                        <p:cTn id="8" dur="1" fill="hold">
+                                        <p:cTn id="14" dur="1" fill="hold">
                                           <p:stCondLst>
                                             <p:cond delay="0"/>
                                           </p:stCondLst>
                                         </p:cTn>
                                         <p:tgtEl>
-                                          <p:spTgt spid="87"/>
-                                        </p:tgtEl>
-                                        <p:attrNameLst>
-                                          <p:attrName>style.visibility</p:attrName>
-                                        </p:attrNameLst>
-                                      </p:cBhvr>
-                                      <p:to>
-                                        <p:strVal val="visible"/>
-                                      </p:to>
-                                    </p:set>
-                                  </p:childTnLst>
-                                </p:cTn>
-                              </p:par>
-                              <p:par>
-                                <p:cTn id="9" presetID="1" presetClass="entr" presetSubtype="0" fill="hold" nodeType="withEffect">
-                                  <p:stCondLst>
-                                    <p:cond delay="0"/>
-                                  </p:stCondLst>
-                                  <p:childTnLst>
-                                    <p:set>
-                                      <p:cBhvr>
-                                        <p:cTn id="10" dur="1" fill="hold">
-                                          <p:stCondLst>
-                                            <p:cond delay="0"/>
-                                          </p:stCondLst>
-                                        </p:cTn>
-                                        <p:tgtEl>
-                                          <p:spTgt spid="88"/>
+                                          <p:spTgt spid="21507"/>
                                         </p:tgtEl>
                                         <p:attrNameLst>
                                           <p:attrName>style.visibility</p:attrName>
@@ -15464,26 +15872,53 @@
                     </p:cTn>
                   </p:par>
                   <p:par>
-                    <p:cTn id="11" fill="hold">
+                    <p:cTn id="15" fill="hold">
                       <p:stCondLst>
                         <p:cond delay="indefinite"/>
                       </p:stCondLst>
                       <p:childTnLst>
                         <p:par>
-                          <p:cTn id="12" fill="hold">
+                          <p:cTn id="16" fill="hold">
                             <p:stCondLst>
                               <p:cond delay="0"/>
                             </p:stCondLst>
                             <p:childTnLst>
                               <p:par>
-                                <p:cTn id="13" presetID="1" presetClass="exit" presetSubtype="0" fill="hold" nodeType="clickEffect">
+                                <p:cTn id="17" presetID="1" presetClass="exit" presetSubtype="0" fill="hold" nodeType="clickEffect">
                                   <p:stCondLst>
                                     <p:cond delay="0"/>
                                   </p:stCondLst>
                                   <p:childTnLst>
                                     <p:set>
                                       <p:cBhvr>
-                                        <p:cTn id="14" dur="1" fill="hold">
+                                        <p:cTn id="18" dur="1" fill="hold">
+                                          <p:stCondLst>
+                                            <p:cond delay="0"/>
+                                          </p:stCondLst>
+                                        </p:cTn>
+                                        <p:tgtEl>
+                                          <p:spTgt spid="60"/>
+                                        </p:tgtEl>
+                                        <p:attrNameLst>
+                                          <p:attrName>style.visibility</p:attrName>
+                                        </p:attrNameLst>
+                                      </p:cBhvr>
+                                      <p:to>
+                                        <p:strVal val="hidden"/>
+                                      </p:to>
+                                    </p:set>
+                                  </p:childTnLst>
+                                </p:cTn>
+                              </p:par>
+                              <p:par>
+                                <p:cTn id="19" presetID="1" presetClass="exit" presetSubtype="0" fill="hold" nodeType="withEffect">
+                                  <p:stCondLst>
+                                    <p:cond delay="0"/>
+                                  </p:stCondLst>
+                                  <p:childTnLst>
+                                    <p:set>
+                                      <p:cBhvr>
+                                        <p:cTn id="20" dur="1" fill="hold">
                                           <p:stCondLst>
                                             <p:cond delay="0"/>
                                           </p:stCondLst>
@@ -15503,20 +15938,20 @@
                                 </p:cTn>
                               </p:par>
                               <p:par>
-                                <p:cTn id="15" presetID="1" presetClass="exit" presetSubtype="0" fill="hold" nodeType="withEffect">
+                                <p:cTn id="21" presetID="1" presetClass="exit" presetSubtype="0" fill="hold" nodeType="withEffect">
                                   <p:stCondLst>
                                     <p:cond delay="0"/>
                                   </p:stCondLst>
                                   <p:childTnLst>
                                     <p:set>
                                       <p:cBhvr>
-                                        <p:cTn id="16" dur="1" fill="hold">
+                                        <p:cTn id="22" dur="1" fill="hold">
                                           <p:stCondLst>
                                             <p:cond delay="0"/>
                                           </p:stCondLst>
                                         </p:cTn>
                                         <p:tgtEl>
-                                          <p:spTgt spid="60"/>
+                                          <p:spTgt spid="16"/>
                                         </p:tgtEl>
                                         <p:attrNameLst>
                                           <p:attrName>style.visibility</p:attrName>
@@ -15530,14 +15965,14 @@
                                 </p:cTn>
                               </p:par>
                               <p:par>
-                                <p:cTn id="17" presetID="1" presetClass="exit" presetSubtype="0" fill="hold" nodeType="withEffect">
+                                <p:cTn id="23" presetID="1" presetClass="exit" presetSubtype="0" fill="hold" nodeType="withEffect">
                                   <p:stCondLst>
                                     <p:cond delay="0"/>
                                   </p:stCondLst>
                                   <p:childTnLst>
                                     <p:set>
                                       <p:cBhvr>
-                                        <p:cTn id="18" dur="1" fill="hold">
+                                        <p:cTn id="24" dur="1" fill="hold">
                                           <p:stCondLst>
                                             <p:cond delay="0"/>
                                           </p:stCondLst>
@@ -15556,39 +15991,48 @@
                                   </p:childTnLst>
                                 </p:cTn>
                               </p:par>
-                            </p:childTnLst>
-                          </p:cTn>
-                        </p:par>
-                      </p:childTnLst>
-                    </p:cTn>
-                  </p:par>
-                  <p:par>
-                    <p:cTn id="19" fill="hold">
-                      <p:stCondLst>
-                        <p:cond delay="indefinite"/>
-                      </p:stCondLst>
-                      <p:childTnLst>
-                        <p:par>
-                          <p:cTn id="20" fill="hold">
-                            <p:stCondLst>
-                              <p:cond delay="0"/>
-                            </p:stCondLst>
-                            <p:childTnLst>
                               <p:par>
-                                <p:cTn id="21" presetID="1" presetClass="entr" presetSubtype="0" fill="hold" nodeType="clickEffect">
+                                <p:cTn id="25" presetID="1" presetClass="exit" presetSubtype="0" fill="hold" nodeType="withEffect">
                                   <p:stCondLst>
                                     <p:cond delay="0"/>
                                   </p:stCondLst>
                                   <p:childTnLst>
                                     <p:set>
                                       <p:cBhvr>
-                                        <p:cTn id="22" dur="1" fill="hold">
+                                        <p:cTn id="26" dur="1" fill="hold">
                                           <p:stCondLst>
                                             <p:cond delay="0"/>
                                           </p:stCondLst>
                                         </p:cTn>
                                         <p:tgtEl>
-                                          <p:spTgt spid="91"/>
+                                          <p:spTgt spid="51"/>
+                                        </p:tgtEl>
+                                        <p:attrNameLst>
+                                          <p:attrName>style.visibility</p:attrName>
+                                        </p:attrNameLst>
+                                      </p:cBhvr>
+                                      <p:to>
+                                        <p:strVal val="hidden"/>
+                                      </p:to>
+                                    </p:set>
+                                  </p:childTnLst>
+                                </p:cTn>
+                              </p:par>
+                              <p:par>
+                                <p:cTn id="27" presetID="1" presetClass="entr" presetSubtype="0" fill="hold" grpId="0" nodeType="withEffect">
+                                  <p:stCondLst>
+                                    <p:cond delay="0"/>
+                                  </p:stCondLst>
+                                  <p:childTnLst>
+                                    <p:set>
+                                      <p:cBhvr>
+                                        <p:cTn id="28" dur="1" fill="hold">
+                                          <p:stCondLst>
+                                            <p:cond delay="0"/>
+                                          </p:stCondLst>
+                                        </p:cTn>
+                                        <p:tgtEl>
+                                          <p:spTgt spid="21549"/>
                                         </p:tgtEl>
                                         <p:attrNameLst>
                                           <p:attrName>style.visibility</p:attrName>
@@ -15601,15 +16045,33 @@
                                   </p:childTnLst>
                                 </p:cTn>
                               </p:par>
+                            </p:childTnLst>
+                          </p:cTn>
+                        </p:par>
+                      </p:childTnLst>
+                    </p:cTn>
+                  </p:par>
+                  <p:par>
+                    <p:cTn id="29" fill="hold">
+                      <p:stCondLst>
+                        <p:cond delay="indefinite"/>
+                      </p:stCondLst>
+                      <p:childTnLst>
+                        <p:par>
+                          <p:cTn id="30" fill="hold">
+                            <p:stCondLst>
+                              <p:cond delay="0"/>
+                            </p:stCondLst>
+                            <p:childTnLst>
                               <p:par>
-                                <p:cTn id="23" presetID="1" presetClass="entr" presetSubtype="0" fill="hold" nodeType="withEffect">
+                                <p:cTn id="31" presetID="1" presetClass="entr" presetSubtype="0" fill="hold" grpId="0" nodeType="clickEffect">
                                   <p:stCondLst>
                                     <p:cond delay="0"/>
                                   </p:stCondLst>
                                   <p:childTnLst>
                                     <p:set>
                                       <p:cBhvr>
-                                        <p:cTn id="24" dur="1" fill="hold">
+                                        <p:cTn id="32" dur="1" fill="hold">
                                           <p:stCondLst>
                                             <p:cond delay="0"/>
                                           </p:stCondLst>
@@ -15635,59 +16097,32 @@
                     </p:cTn>
                   </p:par>
                   <p:par>
-                    <p:cTn id="25" fill="hold">
+                    <p:cTn id="33" fill="hold">
                       <p:stCondLst>
                         <p:cond delay="indefinite"/>
                       </p:stCondLst>
                       <p:childTnLst>
                         <p:par>
-                          <p:cTn id="26" fill="hold">
+                          <p:cTn id="34" fill="hold">
                             <p:stCondLst>
                               <p:cond delay="0"/>
                             </p:stCondLst>
                             <p:childTnLst>
                               <p:par>
-                                <p:cTn id="27" presetID="1" presetClass="exit" presetSubtype="0" fill="hold" nodeType="clickEffect">
+                                <p:cTn id="35" presetID="1" presetClass="exit" presetSubtype="0" fill="hold" nodeType="clickEffect">
                                   <p:stCondLst>
                                     <p:cond delay="0"/>
                                   </p:stCondLst>
                                   <p:childTnLst>
                                     <p:set>
                                       <p:cBhvr>
-                                        <p:cTn id="28" dur="1" fill="hold">
+                                        <p:cTn id="36" dur="1" fill="hold">
                                           <p:stCondLst>
                                             <p:cond delay="0"/>
                                           </p:stCondLst>
                                         </p:cTn>
                                         <p:tgtEl>
                                           <p:spTgt spid="78"/>
-                                        </p:tgtEl>
-                                        <p:attrNameLst>
-                                          <p:attrName>style.visibility</p:attrName>
-                                        </p:attrNameLst>
-                                      </p:cBhvr>
-                                      <p:to>
-                                        <p:strVal val="hidden"/>
-                                      </p:to>
-                                    </p:set>
-                                  </p:childTnLst>
-                                </p:cTn>
-                              </p:par>
-                              <p:par>
-                                <p:cTn id="29" presetID="1" presetClass="exit" presetSubtype="0" fill="hold" nodeType="withEffect">
-                                  <p:stCondLst>
-                                    <p:cond delay="0"/>
-                                  </p:stCondLst>
-                                  <p:childTnLst>
-                                    <p:set>
-                                      <p:cBhvr>
-                                        <p:cTn id="30" dur="1" fill="hold">
-                                          <p:stCondLst>
-                                            <p:cond delay="0"/>
-                                          </p:stCondLst>
-                                        </p:cTn>
-                                        <p:tgtEl>
-                                          <p:spTgt spid="77"/>
                                         </p:tgtEl>
                                         <p:attrNameLst>
                                           <p:attrName>style.visibility</p:attrName>
@@ -15707,100 +16142,19 @@
                     </p:cTn>
                   </p:par>
                   <p:par>
-                    <p:cTn id="31" fill="hold">
+                    <p:cTn id="37" fill="hold">
                       <p:stCondLst>
                         <p:cond delay="indefinite"/>
                       </p:stCondLst>
                       <p:childTnLst>
                         <p:par>
-                          <p:cTn id="32" fill="hold">
+                          <p:cTn id="38" fill="hold">
                             <p:stCondLst>
                               <p:cond delay="0"/>
                             </p:stCondLst>
                             <p:childTnLst>
                               <p:par>
-                                <p:cTn id="33" presetID="1" presetClass="entr" presetSubtype="0" fill="hold" grpId="0" nodeType="clickEffect">
-                                  <p:stCondLst>
-                                    <p:cond delay="0"/>
-                                  </p:stCondLst>
-                                  <p:childTnLst>
-                                    <p:set>
-                                      <p:cBhvr>
-                                        <p:cTn id="34" dur="1" fill="hold">
-                                          <p:stCondLst>
-                                            <p:cond delay="0"/>
-                                          </p:stCondLst>
-                                        </p:cTn>
-                                        <p:tgtEl>
-                                          <p:spTgt spid="94"/>
-                                        </p:tgtEl>
-                                        <p:attrNameLst>
-                                          <p:attrName>style.visibility</p:attrName>
-                                        </p:attrNameLst>
-                                      </p:cBhvr>
-                                      <p:to>
-                                        <p:strVal val="visible"/>
-                                      </p:to>
-                                    </p:set>
-                                  </p:childTnLst>
-                                </p:cTn>
-                              </p:par>
-                              <p:par>
-                                <p:cTn id="35" presetID="1" presetClass="entr" presetSubtype="0" fill="hold" nodeType="withEffect">
-                                  <p:stCondLst>
-                                    <p:cond delay="0"/>
-                                  </p:stCondLst>
-                                  <p:childTnLst>
-                                    <p:set>
-                                      <p:cBhvr>
-                                        <p:cTn id="36" dur="1" fill="hold">
-                                          <p:stCondLst>
-                                            <p:cond delay="0"/>
-                                          </p:stCondLst>
-                                        </p:cTn>
-                                        <p:tgtEl>
-                                          <p:spTgt spid="97"/>
-                                        </p:tgtEl>
-                                        <p:attrNameLst>
-                                          <p:attrName>style.visibility</p:attrName>
-                                        </p:attrNameLst>
-                                      </p:cBhvr>
-                                      <p:to>
-                                        <p:strVal val="visible"/>
-                                      </p:to>
-                                    </p:set>
-                                  </p:childTnLst>
-                                </p:cTn>
-                              </p:par>
-                              <p:par>
-                                <p:cTn id="37" presetID="1" presetClass="entr" presetSubtype="0" fill="hold" grpId="0" nodeType="withEffect">
-                                  <p:stCondLst>
-                                    <p:cond delay="0"/>
-                                  </p:stCondLst>
-                                  <p:childTnLst>
-                                    <p:set>
-                                      <p:cBhvr>
-                                        <p:cTn id="38" dur="1" fill="hold">
-                                          <p:stCondLst>
-                                            <p:cond delay="0"/>
-                                          </p:stCondLst>
-                                        </p:cTn>
-                                        <p:tgtEl>
-                                          <p:spTgt spid="95"/>
-                                        </p:tgtEl>
-                                        <p:attrNameLst>
-                                          <p:attrName>style.visibility</p:attrName>
-                                        </p:attrNameLst>
-                                      </p:cBhvr>
-                                      <p:to>
-                                        <p:strVal val="visible"/>
-                                      </p:to>
-                                    </p:set>
-                                  </p:childTnLst>
-                                </p:cTn>
-                              </p:par>
-                              <p:par>
-                                <p:cTn id="39" presetID="1" presetClass="entr" presetSubtype="0" fill="hold" grpId="0" nodeType="withEffect">
+                                <p:cTn id="39" presetID="1" presetClass="entr" presetSubtype="0" fill="hold" nodeType="clickEffect">
                                   <p:stCondLst>
                                     <p:cond delay="0"/>
                                   </p:stCondLst>
@@ -15813,7 +16167,7 @@
                                           </p:stCondLst>
                                         </p:cTn>
                                         <p:tgtEl>
-                                          <p:spTgt spid="52"/>
+                                          <p:spTgt spid="97"/>
                                         </p:tgtEl>
                                         <p:attrNameLst>
                                           <p:attrName>style.visibility</p:attrName>
@@ -15841,6 +16195,114 @@
                                         </p:cTn>
                                         <p:tgtEl>
                                           <p:spTgt spid="53"/>
+                                        </p:tgtEl>
+                                        <p:attrNameLst>
+                                          <p:attrName>style.visibility</p:attrName>
+                                        </p:attrNameLst>
+                                      </p:cBhvr>
+                                      <p:to>
+                                        <p:strVal val="visible"/>
+                                      </p:to>
+                                    </p:set>
+                                  </p:childTnLst>
+                                </p:cTn>
+                              </p:par>
+                              <p:par>
+                                <p:cTn id="43" presetID="1" presetClass="entr" presetSubtype="0" fill="hold" grpId="0" nodeType="withEffect">
+                                  <p:stCondLst>
+                                    <p:cond delay="0"/>
+                                  </p:stCondLst>
+                                  <p:childTnLst>
+                                    <p:set>
+                                      <p:cBhvr>
+                                        <p:cTn id="44" dur="1" fill="hold">
+                                          <p:stCondLst>
+                                            <p:cond delay="0"/>
+                                          </p:stCondLst>
+                                        </p:cTn>
+                                        <p:tgtEl>
+                                          <p:spTgt spid="95"/>
+                                        </p:tgtEl>
+                                        <p:attrNameLst>
+                                          <p:attrName>style.visibility</p:attrName>
+                                        </p:attrNameLst>
+                                      </p:cBhvr>
+                                      <p:to>
+                                        <p:strVal val="visible"/>
+                                      </p:to>
+                                    </p:set>
+                                  </p:childTnLst>
+                                </p:cTn>
+                              </p:par>
+                              <p:par>
+                                <p:cTn id="45" presetID="1" presetClass="entr" presetSubtype="0" fill="hold" grpId="0" nodeType="withEffect">
+                                  <p:stCondLst>
+                                    <p:cond delay="0"/>
+                                  </p:stCondLst>
+                                  <p:childTnLst>
+                                    <p:set>
+                                      <p:cBhvr>
+                                        <p:cTn id="46" dur="1" fill="hold">
+                                          <p:stCondLst>
+                                            <p:cond delay="0"/>
+                                          </p:stCondLst>
+                                        </p:cTn>
+                                        <p:tgtEl>
+                                          <p:spTgt spid="94"/>
+                                        </p:tgtEl>
+                                        <p:attrNameLst>
+                                          <p:attrName>style.visibility</p:attrName>
+                                        </p:attrNameLst>
+                                      </p:cBhvr>
+                                      <p:to>
+                                        <p:strVal val="visible"/>
+                                      </p:to>
+                                    </p:set>
+                                  </p:childTnLst>
+                                </p:cTn>
+                              </p:par>
+                              <p:par>
+                                <p:cTn id="47" presetID="1" presetClass="entr" presetSubtype="0" fill="hold" grpId="0" nodeType="withEffect">
+                                  <p:stCondLst>
+                                    <p:cond delay="0"/>
+                                  </p:stCondLst>
+                                  <p:childTnLst>
+                                    <p:set>
+                                      <p:cBhvr>
+                                        <p:cTn id="48" dur="1" fill="hold">
+                                          <p:stCondLst>
+                                            <p:cond delay="0"/>
+                                          </p:stCondLst>
+                                        </p:cTn>
+                                        <p:tgtEl>
+                                          <p:spTgt spid="52"/>
+                                        </p:tgtEl>
+                                        <p:attrNameLst>
+                                          <p:attrName>style.visibility</p:attrName>
+                                        </p:attrNameLst>
+                                      </p:cBhvr>
+                                      <p:to>
+                                        <p:strVal val="visible"/>
+                                      </p:to>
+                                    </p:set>
+                                  </p:childTnLst>
+                                </p:cTn>
+                              </p:par>
+                              <p:par>
+                                <p:cTn id="49" presetID="1" presetClass="entr" presetSubtype="0" fill="hold" nodeType="withEffect">
+                                  <p:stCondLst>
+                                    <p:cond delay="0"/>
+                                  </p:stCondLst>
+                                  <p:childTnLst>
+                                    <p:set>
+                                      <p:cBhvr>
+                                        <p:cTn id="50" dur="1" fill="hold">
+                                          <p:stCondLst>
+                                            <p:cond delay="0"/>
+                                          </p:stCondLst>
+                                        </p:cTn>
+                                        <p:tgtEl>
+                                          <p:spTgt spid="21507"/>
                                         </p:tgtEl>
                                         <p:attrNameLst>
                                           <p:attrName>style.visibility</p:attrName>
@@ -15881,9 +16343,14 @@
       </p:par>
     </p:tnLst>
     <p:bldLst>
+      <p:bldP spid="87" grpId="0" animBg="1"/>
+      <p:bldP spid="88" grpId="0" animBg="1"/>
+      <p:bldP spid="90" grpId="0" animBg="1"/>
       <p:bldP spid="94" grpId="0" animBg="1"/>
       <p:bldP spid="95" grpId="0"/>
+      <p:bldP spid="21549" grpId="0"/>
       <p:bldP spid="52" grpId="0" animBg="1"/>
+      <p:bldP spid="15" grpId="0" animBg="1"/>
     </p:bldLst>
   </p:timing>
 </p:sld>

</xml_diff>